<commit_message>
vault backup: 2026-06-25 01:34:52
</commit_message>
<xml_diff>
--- a/ТПР/Презентация_Метод_минимального_элемента.pptx
+++ b/ТПР/Презентация_Метод_минимального_элемента.pptx
@@ -5,19 +5,19 @@
     <p:sldMasterId id="2147483648" r:id="rId1"/>
   </p:sldMasterIdLst>
   <p:sldIdLst>
-    <p:sldId id="256" r:id="rId7"/>
-    <p:sldId id="257" r:id="rId8"/>
-    <p:sldId id="258" r:id="rId9"/>
-    <p:sldId id="259" r:id="rId10"/>
-    <p:sldId id="260" r:id="rId11"/>
-    <p:sldId id="261" r:id="rId12"/>
-    <p:sldId id="262" r:id="rId13"/>
-    <p:sldId id="263" r:id="rId14"/>
-    <p:sldId id="264" r:id="rId15"/>
-    <p:sldId id="265" r:id="rId16"/>
-    <p:sldId id="266" r:id="rId17"/>
+    <p:sldId id="256" r:id="rId2"/>
+    <p:sldId id="257" r:id="rId3"/>
+    <p:sldId id="258" r:id="rId4"/>
+    <p:sldId id="259" r:id="rId5"/>
+    <p:sldId id="260" r:id="rId6"/>
+    <p:sldId id="261" r:id="rId7"/>
+    <p:sldId id="262" r:id="rId8"/>
+    <p:sldId id="263" r:id="rId9"/>
+    <p:sldId id="264" r:id="rId10"/>
+    <p:sldId id="265" r:id="rId11"/>
+    <p:sldId id="266" r:id="rId12"/>
   </p:sldIdLst>
-  <p:sldSz cx="12191695" cy="6858000" type="screen4x3"/>
+  <p:sldSz cx="12192000" cy="6858000"/>
   <p:notesSz cx="6858000" cy="9144000"/>
   <p:defaultTextStyle>
     <a:defPPr>
@@ -114,6 +114,22 @@
       </a:defRPr>
     </a:lvl9pPr>
   </p:defaultTextStyle>
+  <p:extLst>
+    <p:ext uri="{EFAFB233-063F-42B5-8137-9DF3F51BA10A}">
+      <p15:sldGuideLst xmlns:p15="http://schemas.microsoft.com/office/powerpoint/2012/main">
+        <p15:guide id="1" orient="horz" pos="2160">
+          <p15:clr>
+            <a:srgbClr val="A4A3A4"/>
+          </p15:clr>
+        </p15:guide>
+        <p15:guide id="2" pos="2880">
+          <p15:clr>
+            <a:srgbClr val="A4A3A4"/>
+          </p15:clr>
+        </p15:guide>
+      </p15:sldGuideLst>
+    </p:ext>
+  </p:extLst>
 </p:presentation>
 </file>
 
@@ -155,10 +171,9 @@
           <a:lstStyle/>
           <a:p>
             <a:r>
-              <a:rPr lang="en-US" smtClean="0"/>
+              <a:rPr lang="en-US"/>
               <a:t>Click to edit Master title style</a:t>
             </a:r>
-            <a:endParaRPr lang="en-US"/>
           </a:p>
         </p:txBody>
       </p:sp>
@@ -274,10 +289,9 @@
           </a:lstStyle>
           <a:p>
             <a:r>
-              <a:rPr lang="en-US" smtClean="0"/>
+              <a:rPr lang="en-US"/>
               <a:t>Click to edit Master subtitle style</a:t>
             </a:r>
-            <a:endParaRPr lang="en-US"/>
           </a:p>
         </p:txBody>
       </p:sp>
@@ -298,7 +312,7 @@
           <a:p>
             <a:fld id="{5BCAD085-E8A6-8845-BD4E-CB4CCA059FC4}" type="datetimeFigureOut">
               <a:rPr lang="en-US" smtClean="0"/>
-              <a:t>1/27/13</a:t>
+              <a:t>6/24/2026</a:t>
             </a:fld>
             <a:endParaRPr lang="en-US"/>
           </a:p>
@@ -392,10 +406,9 @@
           <a:lstStyle/>
           <a:p>
             <a:r>
-              <a:rPr lang="en-US" smtClean="0"/>
+              <a:rPr lang="en-US"/>
               <a:t>Click to edit Master title style</a:t>
             </a:r>
-            <a:endParaRPr lang="en-US"/>
           </a:p>
         </p:txBody>
       </p:sp>
@@ -416,38 +429,37 @@
           <a:p>
             <a:pPr lvl="0"/>
             <a:r>
-              <a:rPr lang="en-US" smtClean="0"/>
+              <a:rPr lang="en-US"/>
               <a:t>Click to edit Master text styles</a:t>
             </a:r>
           </a:p>
           <a:p>
             <a:pPr lvl="1"/>
             <a:r>
-              <a:rPr lang="en-US" smtClean="0"/>
+              <a:rPr lang="en-US"/>
               <a:t>Second level</a:t>
             </a:r>
           </a:p>
           <a:p>
             <a:pPr lvl="2"/>
             <a:r>
-              <a:rPr lang="en-US" smtClean="0"/>
+              <a:rPr lang="en-US"/>
               <a:t>Third level</a:t>
             </a:r>
           </a:p>
           <a:p>
             <a:pPr lvl="3"/>
             <a:r>
-              <a:rPr lang="en-US" smtClean="0"/>
+              <a:rPr lang="en-US"/>
               <a:t>Fourth level</a:t>
             </a:r>
           </a:p>
           <a:p>
             <a:pPr lvl="4"/>
             <a:r>
-              <a:rPr lang="en-US" smtClean="0"/>
+              <a:rPr lang="en-US"/>
               <a:t>Fifth level</a:t>
             </a:r>
-            <a:endParaRPr lang="en-US"/>
           </a:p>
         </p:txBody>
       </p:sp>
@@ -468,7 +480,7 @@
           <a:p>
             <a:fld id="{5BCAD085-E8A6-8845-BD4E-CB4CCA059FC4}" type="datetimeFigureOut">
               <a:rPr lang="en-US" smtClean="0"/>
-              <a:t>1/27/13</a:t>
+              <a:t>6/24/2026</a:t>
             </a:fld>
             <a:endParaRPr lang="en-US"/>
           </a:p>
@@ -567,10 +579,9 @@
           <a:lstStyle/>
           <a:p>
             <a:r>
-              <a:rPr lang="en-US" smtClean="0"/>
+              <a:rPr lang="en-US"/>
               <a:t>Click to edit Master title style</a:t>
             </a:r>
-            <a:endParaRPr lang="en-US"/>
           </a:p>
         </p:txBody>
       </p:sp>
@@ -596,38 +607,37 @@
           <a:p>
             <a:pPr lvl="0"/>
             <a:r>
-              <a:rPr lang="en-US" smtClean="0"/>
+              <a:rPr lang="en-US"/>
               <a:t>Click to edit Master text styles</a:t>
             </a:r>
           </a:p>
           <a:p>
             <a:pPr lvl="1"/>
             <a:r>
-              <a:rPr lang="en-US" smtClean="0"/>
+              <a:rPr lang="en-US"/>
               <a:t>Second level</a:t>
             </a:r>
           </a:p>
           <a:p>
             <a:pPr lvl="2"/>
             <a:r>
-              <a:rPr lang="en-US" smtClean="0"/>
+              <a:rPr lang="en-US"/>
               <a:t>Third level</a:t>
             </a:r>
           </a:p>
           <a:p>
             <a:pPr lvl="3"/>
             <a:r>
-              <a:rPr lang="en-US" smtClean="0"/>
+              <a:rPr lang="en-US"/>
               <a:t>Fourth level</a:t>
             </a:r>
           </a:p>
           <a:p>
             <a:pPr lvl="4"/>
             <a:r>
-              <a:rPr lang="en-US" smtClean="0"/>
+              <a:rPr lang="en-US"/>
               <a:t>Fifth level</a:t>
             </a:r>
-            <a:endParaRPr lang="en-US"/>
           </a:p>
         </p:txBody>
       </p:sp>
@@ -648,7 +658,7 @@
           <a:p>
             <a:fld id="{5BCAD085-E8A6-8845-BD4E-CB4CCA059FC4}" type="datetimeFigureOut">
               <a:rPr lang="en-US" smtClean="0"/>
-              <a:t>1/27/13</a:t>
+              <a:t>6/24/2026</a:t>
             </a:fld>
             <a:endParaRPr lang="en-US"/>
           </a:p>
@@ -742,10 +752,9 @@
           <a:lstStyle/>
           <a:p>
             <a:r>
-              <a:rPr lang="en-US" smtClean="0"/>
+              <a:rPr lang="en-US"/>
               <a:t>Click to edit Master title style</a:t>
             </a:r>
-            <a:endParaRPr lang="en-US"/>
           </a:p>
         </p:txBody>
       </p:sp>
@@ -766,38 +775,37 @@
           <a:p>
             <a:pPr lvl="0"/>
             <a:r>
-              <a:rPr lang="en-US" smtClean="0"/>
+              <a:rPr lang="en-US"/>
               <a:t>Click to edit Master text styles</a:t>
             </a:r>
           </a:p>
           <a:p>
             <a:pPr lvl="1"/>
             <a:r>
-              <a:rPr lang="en-US" smtClean="0"/>
+              <a:rPr lang="en-US"/>
               <a:t>Second level</a:t>
             </a:r>
           </a:p>
           <a:p>
             <a:pPr lvl="2"/>
             <a:r>
-              <a:rPr lang="en-US" smtClean="0"/>
+              <a:rPr lang="en-US"/>
               <a:t>Third level</a:t>
             </a:r>
           </a:p>
           <a:p>
             <a:pPr lvl="3"/>
             <a:r>
-              <a:rPr lang="en-US" smtClean="0"/>
+              <a:rPr lang="en-US"/>
               <a:t>Fourth level</a:t>
             </a:r>
           </a:p>
           <a:p>
             <a:pPr lvl="4"/>
             <a:r>
-              <a:rPr lang="en-US" smtClean="0"/>
+              <a:rPr lang="en-US"/>
               <a:t>Fifth level</a:t>
             </a:r>
-            <a:endParaRPr lang="en-US"/>
           </a:p>
         </p:txBody>
       </p:sp>
@@ -818,7 +826,7 @@
           <a:p>
             <a:fld id="{5BCAD085-E8A6-8845-BD4E-CB4CCA059FC4}" type="datetimeFigureOut">
               <a:rPr lang="en-US" smtClean="0"/>
-              <a:t>1/27/13</a:t>
+              <a:t>6/24/2026</a:t>
             </a:fld>
             <a:endParaRPr lang="en-US"/>
           </a:p>
@@ -921,10 +929,9 @@
           </a:lstStyle>
           <a:p>
             <a:r>
-              <a:rPr lang="en-US" smtClean="0"/>
+              <a:rPr lang="en-US"/>
               <a:t>Click to edit Master title style</a:t>
             </a:r>
-            <a:endParaRPr lang="en-US"/>
           </a:p>
         </p:txBody>
       </p:sp>
@@ -1041,7 +1048,7 @@
           <a:p>
             <a:pPr lvl="0"/>
             <a:r>
-              <a:rPr lang="en-US" smtClean="0"/>
+              <a:rPr lang="en-US"/>
               <a:t>Click to edit Master text styles</a:t>
             </a:r>
           </a:p>
@@ -1064,7 +1071,7 @@
           <a:p>
             <a:fld id="{5BCAD085-E8A6-8845-BD4E-CB4CCA059FC4}" type="datetimeFigureOut">
               <a:rPr lang="en-US" smtClean="0"/>
-              <a:t>1/27/13</a:t>
+              <a:t>6/24/2026</a:t>
             </a:fld>
             <a:endParaRPr lang="en-US"/>
           </a:p>
@@ -1158,10 +1165,9 @@
           <a:lstStyle/>
           <a:p>
             <a:r>
-              <a:rPr lang="en-US" smtClean="0"/>
+              <a:rPr lang="en-US"/>
               <a:t>Click to edit Master title style</a:t>
             </a:r>
-            <a:endParaRPr lang="en-US"/>
           </a:p>
         </p:txBody>
       </p:sp>
@@ -1215,38 +1221,37 @@
           <a:p>
             <a:pPr lvl="0"/>
             <a:r>
-              <a:rPr lang="en-US" smtClean="0"/>
+              <a:rPr lang="en-US"/>
               <a:t>Click to edit Master text styles</a:t>
             </a:r>
           </a:p>
           <a:p>
             <a:pPr lvl="1"/>
             <a:r>
-              <a:rPr lang="en-US" smtClean="0"/>
+              <a:rPr lang="en-US"/>
               <a:t>Second level</a:t>
             </a:r>
           </a:p>
           <a:p>
             <a:pPr lvl="2"/>
             <a:r>
-              <a:rPr lang="en-US" smtClean="0"/>
+              <a:rPr lang="en-US"/>
               <a:t>Third level</a:t>
             </a:r>
           </a:p>
           <a:p>
             <a:pPr lvl="3"/>
             <a:r>
-              <a:rPr lang="en-US" smtClean="0"/>
+              <a:rPr lang="en-US"/>
               <a:t>Fourth level</a:t>
             </a:r>
           </a:p>
           <a:p>
             <a:pPr lvl="4"/>
             <a:r>
-              <a:rPr lang="en-US" smtClean="0"/>
+              <a:rPr lang="en-US"/>
               <a:t>Fifth level</a:t>
             </a:r>
-            <a:endParaRPr lang="en-US"/>
           </a:p>
         </p:txBody>
       </p:sp>
@@ -1300,38 +1305,37 @@
           <a:p>
             <a:pPr lvl="0"/>
             <a:r>
-              <a:rPr lang="en-US" smtClean="0"/>
+              <a:rPr lang="en-US"/>
               <a:t>Click to edit Master text styles</a:t>
             </a:r>
           </a:p>
           <a:p>
             <a:pPr lvl="1"/>
             <a:r>
-              <a:rPr lang="en-US" smtClean="0"/>
+              <a:rPr lang="en-US"/>
               <a:t>Second level</a:t>
             </a:r>
           </a:p>
           <a:p>
             <a:pPr lvl="2"/>
             <a:r>
-              <a:rPr lang="en-US" smtClean="0"/>
+              <a:rPr lang="en-US"/>
               <a:t>Third level</a:t>
             </a:r>
           </a:p>
           <a:p>
             <a:pPr lvl="3"/>
             <a:r>
-              <a:rPr lang="en-US" smtClean="0"/>
+              <a:rPr lang="en-US"/>
               <a:t>Fourth level</a:t>
             </a:r>
           </a:p>
           <a:p>
             <a:pPr lvl="4"/>
             <a:r>
-              <a:rPr lang="en-US" smtClean="0"/>
+              <a:rPr lang="en-US"/>
               <a:t>Fifth level</a:t>
             </a:r>
-            <a:endParaRPr lang="en-US"/>
           </a:p>
         </p:txBody>
       </p:sp>
@@ -1352,7 +1356,7 @@
           <a:p>
             <a:fld id="{5BCAD085-E8A6-8845-BD4E-CB4CCA059FC4}" type="datetimeFigureOut">
               <a:rPr lang="en-US" smtClean="0"/>
-              <a:t>1/27/13</a:t>
+              <a:t>6/24/2026</a:t>
             </a:fld>
             <a:endParaRPr lang="en-US"/>
           </a:p>
@@ -1450,10 +1454,9 @@
           </a:lstStyle>
           <a:p>
             <a:r>
-              <a:rPr lang="en-US" smtClean="0"/>
+              <a:rPr lang="en-US"/>
               <a:t>Click to edit Master title style</a:t>
             </a:r>
-            <a:endParaRPr lang="en-US"/>
           </a:p>
         </p:txBody>
       </p:sp>
@@ -1516,7 +1519,7 @@
           <a:p>
             <a:pPr lvl="0"/>
             <a:r>
-              <a:rPr lang="en-US" smtClean="0"/>
+              <a:rPr lang="en-US"/>
               <a:t>Click to edit Master text styles</a:t>
             </a:r>
           </a:p>
@@ -1572,38 +1575,37 @@
           <a:p>
             <a:pPr lvl="0"/>
             <a:r>
-              <a:rPr lang="en-US" smtClean="0"/>
+              <a:rPr lang="en-US"/>
               <a:t>Click to edit Master text styles</a:t>
             </a:r>
           </a:p>
           <a:p>
             <a:pPr lvl="1"/>
             <a:r>
-              <a:rPr lang="en-US" smtClean="0"/>
+              <a:rPr lang="en-US"/>
               <a:t>Second level</a:t>
             </a:r>
           </a:p>
           <a:p>
             <a:pPr lvl="2"/>
             <a:r>
-              <a:rPr lang="en-US" smtClean="0"/>
+              <a:rPr lang="en-US"/>
               <a:t>Third level</a:t>
             </a:r>
           </a:p>
           <a:p>
             <a:pPr lvl="3"/>
             <a:r>
-              <a:rPr lang="en-US" smtClean="0"/>
+              <a:rPr lang="en-US"/>
               <a:t>Fourth level</a:t>
             </a:r>
           </a:p>
           <a:p>
             <a:pPr lvl="4"/>
             <a:r>
-              <a:rPr lang="en-US" smtClean="0"/>
+              <a:rPr lang="en-US"/>
               <a:t>Fifth level</a:t>
             </a:r>
-            <a:endParaRPr lang="en-US"/>
           </a:p>
         </p:txBody>
       </p:sp>
@@ -1666,7 +1668,7 @@
           <a:p>
             <a:pPr lvl="0"/>
             <a:r>
-              <a:rPr lang="en-US" smtClean="0"/>
+              <a:rPr lang="en-US"/>
               <a:t>Click to edit Master text styles</a:t>
             </a:r>
           </a:p>
@@ -1722,38 +1724,37 @@
           <a:p>
             <a:pPr lvl="0"/>
             <a:r>
-              <a:rPr lang="en-US" smtClean="0"/>
+              <a:rPr lang="en-US"/>
               <a:t>Click to edit Master text styles</a:t>
             </a:r>
           </a:p>
           <a:p>
             <a:pPr lvl="1"/>
             <a:r>
-              <a:rPr lang="en-US" smtClean="0"/>
+              <a:rPr lang="en-US"/>
               <a:t>Second level</a:t>
             </a:r>
           </a:p>
           <a:p>
             <a:pPr lvl="2"/>
             <a:r>
-              <a:rPr lang="en-US" smtClean="0"/>
+              <a:rPr lang="en-US"/>
               <a:t>Third level</a:t>
             </a:r>
           </a:p>
           <a:p>
             <a:pPr lvl="3"/>
             <a:r>
-              <a:rPr lang="en-US" smtClean="0"/>
+              <a:rPr lang="en-US"/>
               <a:t>Fourth level</a:t>
             </a:r>
           </a:p>
           <a:p>
             <a:pPr lvl="4"/>
             <a:r>
-              <a:rPr lang="en-US" smtClean="0"/>
+              <a:rPr lang="en-US"/>
               <a:t>Fifth level</a:t>
             </a:r>
-            <a:endParaRPr lang="en-US"/>
           </a:p>
         </p:txBody>
       </p:sp>
@@ -1774,7 +1775,7 @@
           <a:p>
             <a:fld id="{5BCAD085-E8A6-8845-BD4E-CB4CCA059FC4}" type="datetimeFigureOut">
               <a:rPr lang="en-US" smtClean="0"/>
-              <a:t>1/27/13</a:t>
+              <a:t>6/24/2026</a:t>
             </a:fld>
             <a:endParaRPr lang="en-US"/>
           </a:p>
@@ -1868,10 +1869,9 @@
           <a:lstStyle/>
           <a:p>
             <a:r>
-              <a:rPr lang="en-US" smtClean="0"/>
+              <a:rPr lang="en-US"/>
               <a:t>Click to edit Master title style</a:t>
             </a:r>
-            <a:endParaRPr lang="en-US"/>
           </a:p>
         </p:txBody>
       </p:sp>
@@ -1892,7 +1892,7 @@
           <a:p>
             <a:fld id="{5BCAD085-E8A6-8845-BD4E-CB4CCA059FC4}" type="datetimeFigureOut">
               <a:rPr lang="en-US" smtClean="0"/>
-              <a:t>1/27/13</a:t>
+              <a:t>6/24/2026</a:t>
             </a:fld>
             <a:endParaRPr lang="en-US"/>
           </a:p>
@@ -1987,7 +1987,7 @@
           <a:p>
             <a:fld id="{5BCAD085-E8A6-8845-BD4E-CB4CCA059FC4}" type="datetimeFigureOut">
               <a:rPr lang="en-US" smtClean="0"/>
-              <a:t>1/27/13</a:t>
+              <a:t>6/24/2026</a:t>
             </a:fld>
             <a:endParaRPr lang="en-US"/>
           </a:p>
@@ -2090,10 +2090,9 @@
           </a:lstStyle>
           <a:p>
             <a:r>
-              <a:rPr lang="en-US" smtClean="0"/>
+              <a:rPr lang="en-US"/>
               <a:t>Click to edit Master title style</a:t>
             </a:r>
-            <a:endParaRPr lang="en-US"/>
           </a:p>
         </p:txBody>
       </p:sp>
@@ -2147,38 +2146,37 @@
           <a:p>
             <a:pPr lvl="0"/>
             <a:r>
-              <a:rPr lang="en-US" smtClean="0"/>
+              <a:rPr lang="en-US"/>
               <a:t>Click to edit Master text styles</a:t>
             </a:r>
           </a:p>
           <a:p>
             <a:pPr lvl="1"/>
             <a:r>
-              <a:rPr lang="en-US" smtClean="0"/>
+              <a:rPr lang="en-US"/>
               <a:t>Second level</a:t>
             </a:r>
           </a:p>
           <a:p>
             <a:pPr lvl="2"/>
             <a:r>
-              <a:rPr lang="en-US" smtClean="0"/>
+              <a:rPr lang="en-US"/>
               <a:t>Third level</a:t>
             </a:r>
           </a:p>
           <a:p>
             <a:pPr lvl="3"/>
             <a:r>
-              <a:rPr lang="en-US" smtClean="0"/>
+              <a:rPr lang="en-US"/>
               <a:t>Fourth level</a:t>
             </a:r>
           </a:p>
           <a:p>
             <a:pPr lvl="4"/>
             <a:r>
-              <a:rPr lang="en-US" smtClean="0"/>
+              <a:rPr lang="en-US"/>
               <a:t>Fifth level</a:t>
             </a:r>
-            <a:endParaRPr lang="en-US"/>
           </a:p>
         </p:txBody>
       </p:sp>
@@ -2241,7 +2239,7 @@
           <a:p>
             <a:pPr lvl="0"/>
             <a:r>
-              <a:rPr lang="en-US" smtClean="0"/>
+              <a:rPr lang="en-US"/>
               <a:t>Click to edit Master text styles</a:t>
             </a:r>
           </a:p>
@@ -2264,7 +2262,7 @@
           <a:p>
             <a:fld id="{5BCAD085-E8A6-8845-BD4E-CB4CCA059FC4}" type="datetimeFigureOut">
               <a:rPr lang="en-US" smtClean="0"/>
-              <a:t>1/27/13</a:t>
+              <a:t>6/24/2026</a:t>
             </a:fld>
             <a:endParaRPr lang="en-US"/>
           </a:p>
@@ -2367,10 +2365,9 @@
           </a:lstStyle>
           <a:p>
             <a:r>
-              <a:rPr lang="en-US" smtClean="0"/>
+              <a:rPr lang="en-US"/>
               <a:t>Click to edit Master title style</a:t>
             </a:r>
-            <a:endParaRPr lang="en-US"/>
           </a:p>
         </p:txBody>
       </p:sp>
@@ -2494,7 +2491,7 @@
           <a:p>
             <a:pPr lvl="0"/>
             <a:r>
-              <a:rPr lang="en-US" smtClean="0"/>
+              <a:rPr lang="en-US"/>
               <a:t>Click to edit Master text styles</a:t>
             </a:r>
           </a:p>
@@ -2517,7 +2514,7 @@
           <a:p>
             <a:fld id="{5BCAD085-E8A6-8845-BD4E-CB4CCA059FC4}" type="datetimeFigureOut">
               <a:rPr lang="en-US" smtClean="0"/>
-              <a:t>1/27/13</a:t>
+              <a:t>6/24/2026</a:t>
             </a:fld>
             <a:endParaRPr lang="en-US"/>
           </a:p>
@@ -2626,10 +2623,9 @@
           <a:lstStyle/>
           <a:p>
             <a:r>
-              <a:rPr lang="en-US" smtClean="0"/>
+              <a:rPr lang="en-US"/>
               <a:t>Click to edit Master title style</a:t>
             </a:r>
-            <a:endParaRPr lang="en-US"/>
           </a:p>
         </p:txBody>
       </p:sp>
@@ -2660,38 +2656,37 @@
           <a:p>
             <a:pPr lvl="0"/>
             <a:r>
-              <a:rPr lang="en-US" smtClean="0"/>
+              <a:rPr lang="en-US"/>
               <a:t>Click to edit Master text styles</a:t>
             </a:r>
           </a:p>
           <a:p>
             <a:pPr lvl="1"/>
             <a:r>
-              <a:rPr lang="en-US" smtClean="0"/>
+              <a:rPr lang="en-US"/>
               <a:t>Second level</a:t>
             </a:r>
           </a:p>
           <a:p>
             <a:pPr lvl="2"/>
             <a:r>
-              <a:rPr lang="en-US" smtClean="0"/>
+              <a:rPr lang="en-US"/>
               <a:t>Third level</a:t>
             </a:r>
           </a:p>
           <a:p>
             <a:pPr lvl="3"/>
             <a:r>
-              <a:rPr lang="en-US" smtClean="0"/>
+              <a:rPr lang="en-US"/>
               <a:t>Fourth level</a:t>
             </a:r>
           </a:p>
           <a:p>
             <a:pPr lvl="4"/>
             <a:r>
-              <a:rPr lang="en-US" smtClean="0"/>
+              <a:rPr lang="en-US"/>
               <a:t>Fifth level</a:t>
             </a:r>
-            <a:endParaRPr lang="en-US"/>
           </a:p>
         </p:txBody>
       </p:sp>
@@ -2730,7 +2725,7 @@
           <a:p>
             <a:fld id="{5BCAD085-E8A6-8845-BD4E-CB4CCA059FC4}" type="datetimeFigureOut">
               <a:rPr lang="en-US" smtClean="0"/>
-              <a:t>1/27/13</a:t>
+              <a:t>6/24/2026</a:t>
             </a:fld>
             <a:endParaRPr lang="en-US"/>
           </a:p>
@@ -3089,7 +3084,7 @@
 </file>
 
 <file path=ppt/slides/slide1.xml><?xml version="1.0" encoding="utf-8"?>
-<p:sld xmlns:a="http://schemas.openxmlformats.org/drawingml/2006/main" xmlns:p="http://schemas.openxmlformats.org/presentationml/2006/main" xmlns:r="http://schemas.openxmlformats.org/officeDocument/2006/relationships">
+<p:sld xmlns:a="http://schemas.openxmlformats.org/drawingml/2006/main" xmlns:r="http://schemas.openxmlformats.org/officeDocument/2006/relationships" xmlns:p="http://schemas.openxmlformats.org/presentationml/2006/main">
   <p:cSld>
     <p:bg>
       <p:bgPr>
@@ -3105,7 +3100,14 @@
         <p:cNvGrpSpPr/>
         <p:nvPr/>
       </p:nvGrpSpPr>
-      <p:grpSpPr/>
+      <p:grpSpPr>
+        <a:xfrm>
+          <a:off x="0" y="0"/>
+          <a:ext cx="0" cy="0"/>
+          <a:chOff x="0" y="0"/>
+          <a:chExt cx="0" cy="0"/>
+        </a:xfrm>
+      </p:grpSpPr>
       <p:sp>
         <p:nvSpPr>
           <p:cNvPr id="2" name="TextBox 1"/>
@@ -3115,7 +3117,7 @@
         <p:spPr>
           <a:xfrm>
             <a:off x="731520" y="1828800"/>
-            <a:ext cx="10515600" cy="2011680"/>
+            <a:ext cx="10515600" cy="1661993"/>
           </a:xfrm>
           <a:prstGeom prst="rect">
             <a:avLst/>
@@ -3137,22 +3139,35 @@
               </a:defRPr>
             </a:pPr>
             <a:r>
+              <a:rPr dirty="0"/>
               <a:t>САМОСТОЯТЕЛЬНАЯ РАБОТА • ТПР</a:t>
             </a:r>
           </a:p>
           <a:p>
-            <a:br/>
-            <a:pPr>
-              <a:defRPr sz="4400" b="1">
-                <a:solidFill>
-                  <a:srgbClr val="0F172A"/>
-                </a:solidFill>
-                <a:latin typeface="Arial"/>
-              </a:defRPr>
-            </a:pPr>
-            <a:r>
-              <a:t>Метод минимального элемента</a:t>
-            </a:r>
+            <a:br>
+              <a:rPr sz="4400" b="1" dirty="0"/>
+            </a:br>
+            <a:r>
+              <a:rPr sz="4400" b="1" dirty="0" err="1"/>
+              <a:t>Метод</a:t>
+            </a:r>
+            <a:r>
+              <a:rPr sz="4400" b="1" dirty="0"/>
+              <a:t> </a:t>
+            </a:r>
+            <a:r>
+              <a:rPr sz="4400" b="1" dirty="0" err="1"/>
+              <a:t>минимального</a:t>
+            </a:r>
+            <a:r>
+              <a:rPr sz="4400" b="1" dirty="0"/>
+              <a:t> </a:t>
+            </a:r>
+            <a:r>
+              <a:rPr sz="4400" b="1" dirty="0" err="1"/>
+              <a:t>элемента</a:t>
+            </a:r>
+            <a:endParaRPr sz="4400" b="1" dirty="0"/>
           </a:p>
         </p:txBody>
       </p:sp>
@@ -3196,6 +3211,7 @@
           <a:lstStyle/>
           <a:p>
             <a:pPr algn="ctr"/>
+            <a:endParaRPr/>
           </a:p>
         </p:txBody>
       </p:sp>
@@ -3248,7 +3264,7 @@
 </file>
 
 <file path=ppt/slides/slide10.xml><?xml version="1.0" encoding="utf-8"?>
-<p:sld xmlns:a="http://schemas.openxmlformats.org/drawingml/2006/main" xmlns:p="http://schemas.openxmlformats.org/presentationml/2006/main" xmlns:r="http://schemas.openxmlformats.org/officeDocument/2006/relationships">
+<p:sld xmlns:a="http://schemas.openxmlformats.org/drawingml/2006/main" xmlns:r="http://schemas.openxmlformats.org/officeDocument/2006/relationships" xmlns:p="http://schemas.openxmlformats.org/presentationml/2006/main">
   <p:cSld>
     <p:bg>
       <p:bgPr>
@@ -3264,7 +3280,14 @@
         <p:cNvGrpSpPr/>
         <p:nvPr/>
       </p:nvGrpSpPr>
-      <p:grpSpPr/>
+      <p:grpSpPr>
+        <a:xfrm>
+          <a:off x="0" y="0"/>
+          <a:ext cx="0" cy="0"/>
+          <a:chOff x="0" y="0"/>
+          <a:chExt cx="0" cy="0"/>
+        </a:xfrm>
+      </p:grpSpPr>
       <p:sp>
         <p:nvSpPr>
           <p:cNvPr id="2" name="TextBox 1"/>
@@ -3377,6 +3400,7 @@
           <a:lstStyle/>
           <a:p>
             <a:pPr algn="ctr"/>
+            <a:endParaRPr/>
           </a:p>
         </p:txBody>
       </p:sp>
@@ -3416,14 +3440,6 @@
           </a:p>
           <a:p>
             <a:br/>
-            <a:pPr>
-              <a:defRPr sz="2200">
-                <a:solidFill>
-                  <a:srgbClr val="0F172A"/>
-                </a:solidFill>
-                <a:latin typeface="Calibri"/>
-              </a:defRPr>
-            </a:pPr>
             <a:r>
               <a:t>• Простота расчетов.</a:t>
             </a:r>
@@ -3478,14 +3494,6 @@
           </a:p>
           <a:p>
             <a:br/>
-            <a:pPr>
-              <a:defRPr sz="2200">
-                <a:solidFill>
-                  <a:srgbClr val="0F172A"/>
-                </a:solidFill>
-                <a:latin typeface="Calibri"/>
-              </a:defRPr>
-            </a:pPr>
             <a:r>
               <a:t>• Локальная «жадность».</a:t>
             </a:r>
@@ -3509,7 +3517,7 @@
 </file>
 
 <file path=ppt/slides/slide11.xml><?xml version="1.0" encoding="utf-8"?>
-<p:sld xmlns:a="http://schemas.openxmlformats.org/drawingml/2006/main" xmlns:p="http://schemas.openxmlformats.org/presentationml/2006/main" xmlns:r="http://schemas.openxmlformats.org/officeDocument/2006/relationships">
+<p:sld xmlns:a="http://schemas.openxmlformats.org/drawingml/2006/main" xmlns:r="http://schemas.openxmlformats.org/officeDocument/2006/relationships" xmlns:p="http://schemas.openxmlformats.org/presentationml/2006/main">
   <p:cSld>
     <p:bg>
       <p:bgPr>
@@ -3525,7 +3533,14 @@
         <p:cNvGrpSpPr/>
         <p:nvPr/>
       </p:nvGrpSpPr>
-      <p:grpSpPr/>
+      <p:grpSpPr>
+        <a:xfrm>
+          <a:off x="0" y="0"/>
+          <a:ext cx="0" cy="0"/>
+          <a:chOff x="0" y="0"/>
+          <a:chExt cx="0" cy="0"/>
+        </a:xfrm>
+      </p:grpSpPr>
       <p:sp>
         <p:nvSpPr>
           <p:cNvPr id="2" name="TextBox 1"/>
@@ -3638,6 +3653,7 @@
           <a:lstStyle/>
           <a:p>
             <a:pPr algn="ctr"/>
+            <a:endParaRPr/>
           </a:p>
         </p:txBody>
       </p:sp>
@@ -3677,14 +3693,6 @@
           </a:p>
           <a:p>
             <a:br/>
-            <a:pPr>
-              <a:defRPr sz="2400">
-                <a:solidFill>
-                  <a:srgbClr val="0F172A"/>
-                </a:solidFill>
-                <a:latin typeface="Calibri"/>
-              </a:defRPr>
-            </a:pPr>
             <a:r>
               <a:t>Оптимальный баланс простоты и качества начального решения.</a:t>
             </a:r>
@@ -3705,7 +3713,7 @@
 </file>
 
 <file path=ppt/slides/slide2.xml><?xml version="1.0" encoding="utf-8"?>
-<p:sld xmlns:a="http://schemas.openxmlformats.org/drawingml/2006/main" xmlns:p="http://schemas.openxmlformats.org/presentationml/2006/main" xmlns:r="http://schemas.openxmlformats.org/officeDocument/2006/relationships">
+<p:sld xmlns:a="http://schemas.openxmlformats.org/drawingml/2006/main" xmlns:r="http://schemas.openxmlformats.org/officeDocument/2006/relationships" xmlns:p="http://schemas.openxmlformats.org/presentationml/2006/main">
   <p:cSld>
     <p:bg>
       <p:bgPr>
@@ -3721,7 +3729,14 @@
         <p:cNvGrpSpPr/>
         <p:nvPr/>
       </p:nvGrpSpPr>
-      <p:grpSpPr/>
+      <p:grpSpPr>
+        <a:xfrm>
+          <a:off x="0" y="0"/>
+          <a:ext cx="0" cy="0"/>
+          <a:chOff x="0" y="0"/>
+          <a:chExt cx="0" cy="0"/>
+        </a:xfrm>
+      </p:grpSpPr>
       <p:sp>
         <p:nvSpPr>
           <p:cNvPr id="2" name="TextBox 1"/>
@@ -3834,6 +3849,7 @@
           <a:lstStyle/>
           <a:p>
             <a:pPr algn="ctr"/>
+            <a:endParaRPr/>
           </a:p>
         </p:txBody>
       </p:sp>
@@ -3873,14 +3889,6 @@
           </a:p>
           <a:p>
             <a:br/>
-            <a:pPr>
-              <a:defRPr sz="2200">
-                <a:solidFill>
-                  <a:srgbClr val="475569"/>
-                </a:solidFill>
-                <a:latin typeface="Calibri"/>
-              </a:defRPr>
-            </a:pPr>
             <a:r>
               <a:t>Оптимальная доставка однородного груза от поставщиков к потребителям.</a:t>
             </a:r>
@@ -3951,14 +3959,6 @@
           </a:p>
           <a:p>
             <a:br/>
-            <a:pPr>
-              <a:defRPr sz="2200" b="1">
-                <a:solidFill>
-                  <a:srgbClr val="0F172A"/>
-                </a:solidFill>
-                <a:latin typeface="Arial"/>
-              </a:defRPr>
-            </a:pPr>
             <a:r>
               <a:t>Ограничения:</a:t>
             </a:r>
@@ -4016,7 +4016,7 @@
 </file>
 
 <file path=ppt/slides/slide3.xml><?xml version="1.0" encoding="utf-8"?>
-<p:sld xmlns:a="http://schemas.openxmlformats.org/drawingml/2006/main" xmlns:p="http://schemas.openxmlformats.org/presentationml/2006/main" xmlns:r="http://schemas.openxmlformats.org/officeDocument/2006/relationships">
+<p:sld xmlns:a="http://schemas.openxmlformats.org/drawingml/2006/main" xmlns:r="http://schemas.openxmlformats.org/officeDocument/2006/relationships" xmlns:p="http://schemas.openxmlformats.org/presentationml/2006/main">
   <p:cSld>
     <p:bg>
       <p:bgPr>
@@ -4032,7 +4032,14 @@
         <p:cNvGrpSpPr/>
         <p:nvPr/>
       </p:nvGrpSpPr>
-      <p:grpSpPr/>
+      <p:grpSpPr>
+        <a:xfrm>
+          <a:off x="0" y="0"/>
+          <a:ext cx="0" cy="0"/>
+          <a:chOff x="0" y="0"/>
+          <a:chExt cx="0" cy="0"/>
+        </a:xfrm>
+      </p:grpSpPr>
       <p:sp>
         <p:nvSpPr>
           <p:cNvPr id="2" name="TextBox 1"/>
@@ -4145,6 +4152,7 @@
           <a:lstStyle/>
           <a:p>
             <a:pPr algn="ctr"/>
+            <a:endParaRPr/>
           </a:p>
         </p:txBody>
       </p:sp>
@@ -4182,6 +4190,7 @@
               <a:t>1. Быстрое построение первоначального допустимого плана перевозок.</a:t>
             </a:r>
             <a:br/>
+            <a:endParaRPr/>
           </a:p>
           <a:p>
             <a:pPr>
@@ -4196,6 +4205,7 @@
               <a:t>2. Учет реальных тарифов перевозок при составлении маршрутов.</a:t>
             </a:r>
             <a:br/>
+            <a:endParaRPr/>
           </a:p>
           <a:p>
             <a:pPr>
@@ -4210,6 +4220,7 @@
               <a:t>3. Значительное сокращение количества последующих шагов оптимизации.</a:t>
             </a:r>
             <a:br/>
+            <a:endParaRPr/>
           </a:p>
         </p:txBody>
       </p:sp>
@@ -4222,7 +4233,7 @@
 </file>
 
 <file path=ppt/slides/slide4.xml><?xml version="1.0" encoding="utf-8"?>
-<p:sld xmlns:a="http://schemas.openxmlformats.org/drawingml/2006/main" xmlns:p="http://schemas.openxmlformats.org/presentationml/2006/main" xmlns:r="http://schemas.openxmlformats.org/officeDocument/2006/relationships">
+<p:sld xmlns:a="http://schemas.openxmlformats.org/drawingml/2006/main" xmlns:r="http://schemas.openxmlformats.org/officeDocument/2006/relationships" xmlns:p="http://schemas.openxmlformats.org/presentationml/2006/main">
   <p:cSld>
     <p:bg>
       <p:bgPr>
@@ -4238,7 +4249,14 @@
         <p:cNvGrpSpPr/>
         <p:nvPr/>
       </p:nvGrpSpPr>
-      <p:grpSpPr/>
+      <p:grpSpPr>
+        <a:xfrm>
+          <a:off x="0" y="0"/>
+          <a:ext cx="0" cy="0"/>
+          <a:chOff x="0" y="0"/>
+          <a:chExt cx="0" cy="0"/>
+        </a:xfrm>
+      </p:grpSpPr>
       <p:sp>
         <p:nvSpPr>
           <p:cNvPr id="2" name="TextBox 1"/>
@@ -4351,6 +4369,7 @@
           <a:lstStyle/>
           <a:p>
             <a:pPr algn="ctr"/>
+            <a:endParaRPr/>
           </a:p>
         </p:txBody>
       </p:sp>
@@ -4390,14 +4409,6 @@
           </a:p>
           <a:p>
             <a:br/>
-            <a:pPr>
-              <a:defRPr sz="2400">
-                <a:solidFill>
-                  <a:srgbClr val="0F172A"/>
-                </a:solidFill>
-                <a:latin typeface="Calibri"/>
-              </a:defRPr>
-            </a:pPr>
             <a:r>
               <a:t>Приоритетное заполнение клеток таблицы с наименьшей стоимостью перевозок.</a:t>
             </a:r>
@@ -4418,7 +4429,7 @@
 </file>
 
 <file path=ppt/slides/slide5.xml><?xml version="1.0" encoding="utf-8"?>
-<p:sld xmlns:a="http://schemas.openxmlformats.org/drawingml/2006/main" xmlns:p="http://schemas.openxmlformats.org/presentationml/2006/main" xmlns:r="http://schemas.openxmlformats.org/officeDocument/2006/relationships">
+<p:sld xmlns:a="http://schemas.openxmlformats.org/drawingml/2006/main" xmlns:r="http://schemas.openxmlformats.org/officeDocument/2006/relationships" xmlns:p="http://schemas.openxmlformats.org/presentationml/2006/main">
   <p:cSld>
     <p:bg>
       <p:bgPr>
@@ -4434,7 +4445,14 @@
         <p:cNvGrpSpPr/>
         <p:nvPr/>
       </p:nvGrpSpPr>
-      <p:grpSpPr/>
+      <p:grpSpPr>
+        <a:xfrm>
+          <a:off x="0" y="0"/>
+          <a:ext cx="0" cy="0"/>
+          <a:chOff x="0" y="0"/>
+          <a:chExt cx="0" cy="0"/>
+        </a:xfrm>
+      </p:grpSpPr>
       <p:sp>
         <p:nvSpPr>
           <p:cNvPr id="2" name="TextBox 1"/>
@@ -4547,6 +4565,7 @@
           <a:lstStyle/>
           <a:p>
             <a:pPr algn="ctr"/>
+            <a:endParaRPr/>
           </a:p>
         </p:txBody>
       </p:sp>
@@ -4664,7 +4683,7 @@
 </file>
 
 <file path=ppt/slides/slide6.xml><?xml version="1.0" encoding="utf-8"?>
-<p:sld xmlns:a="http://schemas.openxmlformats.org/drawingml/2006/main" xmlns:p="http://schemas.openxmlformats.org/presentationml/2006/main" xmlns:r="http://schemas.openxmlformats.org/officeDocument/2006/relationships">
+<p:sld xmlns:a="http://schemas.openxmlformats.org/drawingml/2006/main" xmlns:r="http://schemas.openxmlformats.org/officeDocument/2006/relationships" xmlns:p="http://schemas.openxmlformats.org/presentationml/2006/main">
   <p:cSld>
     <p:bg>
       <p:bgPr>
@@ -4680,7 +4699,14 @@
         <p:cNvGrpSpPr/>
         <p:nvPr/>
       </p:nvGrpSpPr>
-      <p:grpSpPr/>
+      <p:grpSpPr>
+        <a:xfrm>
+          <a:off x="0" y="0"/>
+          <a:ext cx="0" cy="0"/>
+          <a:chOff x="0" y="0"/>
+          <a:chExt cx="0" cy="0"/>
+        </a:xfrm>
+      </p:grpSpPr>
       <p:sp>
         <p:nvSpPr>
           <p:cNvPr id="2" name="TextBox 1"/>
@@ -4793,6 +4819,7 @@
           <a:lstStyle/>
           <a:p>
             <a:pPr algn="ctr"/>
+            <a:endParaRPr/>
           </a:p>
         </p:txBody>
       </p:sp>
@@ -4815,11 +4842,41 @@
                 <a:tableStyleId>{5C22544A-7EE6-4342-B048-85BDC9FD1C3A}</a:tableStyleId>
               </a:tblPr>
               <a:tblGrid>
-                <a:gridCol w="1889150"/>
-                <a:gridCol w="1889150"/>
-                <a:gridCol w="1889150"/>
-                <a:gridCol w="1889150"/>
-                <a:gridCol w="1889152"/>
+                <a:gridCol w="1889150">
+                  <a:extLst>
+                    <a:ext uri="{9D8B030D-6E8A-4147-A177-3AD203B41FA5}">
+                      <a16:colId xmlns:a16="http://schemas.microsoft.com/office/drawing/2014/main" val="20000"/>
+                    </a:ext>
+                  </a:extLst>
+                </a:gridCol>
+                <a:gridCol w="1889150">
+                  <a:extLst>
+                    <a:ext uri="{9D8B030D-6E8A-4147-A177-3AD203B41FA5}">
+                      <a16:colId xmlns:a16="http://schemas.microsoft.com/office/drawing/2014/main" val="20001"/>
+                    </a:ext>
+                  </a:extLst>
+                </a:gridCol>
+                <a:gridCol w="1889150">
+                  <a:extLst>
+                    <a:ext uri="{9D8B030D-6E8A-4147-A177-3AD203B41FA5}">
+                      <a16:colId xmlns:a16="http://schemas.microsoft.com/office/drawing/2014/main" val="20002"/>
+                    </a:ext>
+                  </a:extLst>
+                </a:gridCol>
+                <a:gridCol w="1889150">
+                  <a:extLst>
+                    <a:ext uri="{9D8B030D-6E8A-4147-A177-3AD203B41FA5}">
+                      <a16:colId xmlns:a16="http://schemas.microsoft.com/office/drawing/2014/main" val="20003"/>
+                    </a:ext>
+                  </a:extLst>
+                </a:gridCol>
+                <a:gridCol w="1889152">
+                  <a:extLst>
+                    <a:ext uri="{9D8B030D-6E8A-4147-A177-3AD203B41FA5}">
+                      <a16:colId xmlns:a16="http://schemas.microsoft.com/office/drawing/2014/main" val="20004"/>
+                    </a:ext>
+                  </a:extLst>
+                </a:gridCol>
               </a:tblGrid>
               <a:tr h="822960">
                 <a:tc>
@@ -4942,6 +4999,11 @@
                     </a:solidFill>
                   </a:tcPr>
                 </a:tc>
+                <a:extLst>
+                  <a:ext uri="{0D108BD9-81ED-4DB2-BD59-A6C34878D82A}">
+                    <a16:rowId xmlns:a16="http://schemas.microsoft.com/office/drawing/2014/main" val="10000"/>
+                  </a:ext>
+                </a:extLst>
               </a:tr>
               <a:tr h="822960">
                 <a:tc>
@@ -5064,6 +5126,11 @@
                     </a:solidFill>
                   </a:tcPr>
                 </a:tc>
+                <a:extLst>
+                  <a:ext uri="{0D108BD9-81ED-4DB2-BD59-A6C34878D82A}">
+                    <a16:rowId xmlns:a16="http://schemas.microsoft.com/office/drawing/2014/main" val="10001"/>
+                  </a:ext>
+                </a:extLst>
               </a:tr>
               <a:tr h="822960">
                 <a:tc>
@@ -5186,6 +5253,11 @@
                     </a:solidFill>
                   </a:tcPr>
                 </a:tc>
+                <a:extLst>
+                  <a:ext uri="{0D108BD9-81ED-4DB2-BD59-A6C34878D82A}">
+                    <a16:rowId xmlns:a16="http://schemas.microsoft.com/office/drawing/2014/main" val="10002"/>
+                  </a:ext>
+                </a:extLst>
               </a:tr>
               <a:tr h="822960">
                 <a:tc>
@@ -5308,6 +5380,11 @@
                     </a:solidFill>
                   </a:tcPr>
                 </a:tc>
+                <a:extLst>
+                  <a:ext uri="{0D108BD9-81ED-4DB2-BD59-A6C34878D82A}">
+                    <a16:rowId xmlns:a16="http://schemas.microsoft.com/office/drawing/2014/main" val="10003"/>
+                  </a:ext>
+                </a:extLst>
               </a:tr>
               <a:tr h="822960">
                 <a:tc>
@@ -5430,6 +5507,11 @@
                     </a:solidFill>
                   </a:tcPr>
                 </a:tc>
+                <a:extLst>
+                  <a:ext uri="{0D108BD9-81ED-4DB2-BD59-A6C34878D82A}">
+                    <a16:rowId xmlns:a16="http://schemas.microsoft.com/office/drawing/2014/main" val="10004"/>
+                  </a:ext>
+                </a:extLst>
               </a:tr>
             </a:tbl>
           </a:graphicData>
@@ -5444,7 +5526,7 @@
 </file>
 
 <file path=ppt/slides/slide7.xml><?xml version="1.0" encoding="utf-8"?>
-<p:sld xmlns:a="http://schemas.openxmlformats.org/drawingml/2006/main" xmlns:p="http://schemas.openxmlformats.org/presentationml/2006/main" xmlns:r="http://schemas.openxmlformats.org/officeDocument/2006/relationships">
+<p:sld xmlns:a="http://schemas.openxmlformats.org/drawingml/2006/main" xmlns:r="http://schemas.openxmlformats.org/officeDocument/2006/relationships" xmlns:p="http://schemas.openxmlformats.org/presentationml/2006/main">
   <p:cSld>
     <p:bg>
       <p:bgPr>
@@ -5460,7 +5542,14 @@
         <p:cNvGrpSpPr/>
         <p:nvPr/>
       </p:nvGrpSpPr>
-      <p:grpSpPr/>
+      <p:grpSpPr>
+        <a:xfrm>
+          <a:off x="0" y="0"/>
+          <a:ext cx="0" cy="0"/>
+          <a:chOff x="0" y="0"/>
+          <a:chExt cx="0" cy="0"/>
+        </a:xfrm>
+      </p:grpSpPr>
       <p:sp>
         <p:nvSpPr>
           <p:cNvPr id="2" name="TextBox 1"/>
@@ -5573,6 +5662,7 @@
           <a:lstStyle/>
           <a:p>
             <a:pPr algn="ctr"/>
+            <a:endParaRPr/>
           </a:p>
         </p:txBody>
       </p:sp>
@@ -5595,11 +5685,41 @@
                 <a:tableStyleId>{5C22544A-7EE6-4342-B048-85BDC9FD1C3A}</a:tableStyleId>
               </a:tblPr>
               <a:tblGrid>
-                <a:gridCol w="1097280"/>
-                <a:gridCol w="1097280"/>
-                <a:gridCol w="1097280"/>
-                <a:gridCol w="1097280"/>
-                <a:gridCol w="1097280"/>
+                <a:gridCol w="1097280">
+                  <a:extLst>
+                    <a:ext uri="{9D8B030D-6E8A-4147-A177-3AD203B41FA5}">
+                      <a16:colId xmlns:a16="http://schemas.microsoft.com/office/drawing/2014/main" val="20000"/>
+                    </a:ext>
+                  </a:extLst>
+                </a:gridCol>
+                <a:gridCol w="1097280">
+                  <a:extLst>
+                    <a:ext uri="{9D8B030D-6E8A-4147-A177-3AD203B41FA5}">
+                      <a16:colId xmlns:a16="http://schemas.microsoft.com/office/drawing/2014/main" val="20001"/>
+                    </a:ext>
+                  </a:extLst>
+                </a:gridCol>
+                <a:gridCol w="1097280">
+                  <a:extLst>
+                    <a:ext uri="{9D8B030D-6E8A-4147-A177-3AD203B41FA5}">
+                      <a16:colId xmlns:a16="http://schemas.microsoft.com/office/drawing/2014/main" val="20002"/>
+                    </a:ext>
+                  </a:extLst>
+                </a:gridCol>
+                <a:gridCol w="1097280">
+                  <a:extLst>
+                    <a:ext uri="{9D8B030D-6E8A-4147-A177-3AD203B41FA5}">
+                      <a16:colId xmlns:a16="http://schemas.microsoft.com/office/drawing/2014/main" val="20003"/>
+                    </a:ext>
+                  </a:extLst>
+                </a:gridCol>
+                <a:gridCol w="1097280">
+                  <a:extLst>
+                    <a:ext uri="{9D8B030D-6E8A-4147-A177-3AD203B41FA5}">
+                      <a16:colId xmlns:a16="http://schemas.microsoft.com/office/drawing/2014/main" val="20004"/>
+                    </a:ext>
+                  </a:extLst>
+                </a:gridCol>
               </a:tblGrid>
               <a:tr h="822960">
                 <a:tc>
@@ -5722,6 +5842,11 @@
                     </a:solidFill>
                   </a:tcPr>
                 </a:tc>
+                <a:extLst>
+                  <a:ext uri="{0D108BD9-81ED-4DB2-BD59-A6C34878D82A}">
+                    <a16:rowId xmlns:a16="http://schemas.microsoft.com/office/drawing/2014/main" val="10000"/>
+                  </a:ext>
+                </a:extLst>
               </a:tr>
               <a:tr h="822960">
                 <a:tc>
@@ -5844,6 +5969,11 @@
                     </a:solidFill>
                   </a:tcPr>
                 </a:tc>
+                <a:extLst>
+                  <a:ext uri="{0D108BD9-81ED-4DB2-BD59-A6C34878D82A}">
+                    <a16:rowId xmlns:a16="http://schemas.microsoft.com/office/drawing/2014/main" val="10001"/>
+                  </a:ext>
+                </a:extLst>
               </a:tr>
               <a:tr h="822960">
                 <a:tc>
@@ -5966,6 +6096,11 @@
                     </a:solidFill>
                   </a:tcPr>
                 </a:tc>
+                <a:extLst>
+                  <a:ext uri="{0D108BD9-81ED-4DB2-BD59-A6C34878D82A}">
+                    <a16:rowId xmlns:a16="http://schemas.microsoft.com/office/drawing/2014/main" val="10002"/>
+                  </a:ext>
+                </a:extLst>
               </a:tr>
               <a:tr h="822960">
                 <a:tc>
@@ -6088,6 +6223,11 @@
                     </a:solidFill>
                   </a:tcPr>
                 </a:tc>
+                <a:extLst>
+                  <a:ext uri="{0D108BD9-81ED-4DB2-BD59-A6C34878D82A}">
+                    <a16:rowId xmlns:a16="http://schemas.microsoft.com/office/drawing/2014/main" val="10003"/>
+                  </a:ext>
+                </a:extLst>
               </a:tr>
               <a:tr h="822960">
                 <a:tc>
@@ -6210,6 +6350,11 @@
                     </a:solidFill>
                   </a:tcPr>
                 </a:tc>
+                <a:extLst>
+                  <a:ext uri="{0D108BD9-81ED-4DB2-BD59-A6C34878D82A}">
+                    <a16:rowId xmlns:a16="http://schemas.microsoft.com/office/drawing/2014/main" val="10004"/>
+                  </a:ext>
+                </a:extLst>
               </a:tr>
             </a:tbl>
           </a:graphicData>
@@ -6285,6 +6430,7 @@
               <a:t>Запасы поставщика A2 исчерпаны. Спрос B2 снижается до 10.</a:t>
             </a:r>
             <a:br/>
+            <a:endParaRPr/>
           </a:p>
           <a:p>
             <a:pPr>
@@ -6343,7 +6489,7 @@
 </file>
 
 <file path=ppt/slides/slide8.xml><?xml version="1.0" encoding="utf-8"?>
-<p:sld xmlns:a="http://schemas.openxmlformats.org/drawingml/2006/main" xmlns:p="http://schemas.openxmlformats.org/presentationml/2006/main" xmlns:r="http://schemas.openxmlformats.org/officeDocument/2006/relationships">
+<p:sld xmlns:a="http://schemas.openxmlformats.org/drawingml/2006/main" xmlns:r="http://schemas.openxmlformats.org/officeDocument/2006/relationships" xmlns:p="http://schemas.openxmlformats.org/presentationml/2006/main">
   <p:cSld>
     <p:bg>
       <p:bgPr>
@@ -6359,7 +6505,14 @@
         <p:cNvGrpSpPr/>
         <p:nvPr/>
       </p:nvGrpSpPr>
-      <p:grpSpPr/>
+      <p:grpSpPr>
+        <a:xfrm>
+          <a:off x="0" y="0"/>
+          <a:ext cx="0" cy="0"/>
+          <a:chOff x="0" y="0"/>
+          <a:chExt cx="0" cy="0"/>
+        </a:xfrm>
+      </p:grpSpPr>
       <p:sp>
         <p:nvSpPr>
           <p:cNvPr id="2" name="TextBox 1"/>
@@ -6472,6 +6625,7 @@
           <a:lstStyle/>
           <a:p>
             <a:pPr algn="ctr"/>
+            <a:endParaRPr/>
           </a:p>
         </p:txBody>
       </p:sp>
@@ -6494,11 +6648,41 @@
                 <a:tableStyleId>{5C22544A-7EE6-4342-B048-85BDC9FD1C3A}</a:tableStyleId>
               </a:tblPr>
               <a:tblGrid>
-                <a:gridCol w="1097280"/>
-                <a:gridCol w="1097280"/>
-                <a:gridCol w="1097280"/>
-                <a:gridCol w="1097280"/>
-                <a:gridCol w="1097280"/>
+                <a:gridCol w="1097280">
+                  <a:extLst>
+                    <a:ext uri="{9D8B030D-6E8A-4147-A177-3AD203B41FA5}">
+                      <a16:colId xmlns:a16="http://schemas.microsoft.com/office/drawing/2014/main" val="20000"/>
+                    </a:ext>
+                  </a:extLst>
+                </a:gridCol>
+                <a:gridCol w="1097280">
+                  <a:extLst>
+                    <a:ext uri="{9D8B030D-6E8A-4147-A177-3AD203B41FA5}">
+                      <a16:colId xmlns:a16="http://schemas.microsoft.com/office/drawing/2014/main" val="20001"/>
+                    </a:ext>
+                  </a:extLst>
+                </a:gridCol>
+                <a:gridCol w="1097280">
+                  <a:extLst>
+                    <a:ext uri="{9D8B030D-6E8A-4147-A177-3AD203B41FA5}">
+                      <a16:colId xmlns:a16="http://schemas.microsoft.com/office/drawing/2014/main" val="20002"/>
+                    </a:ext>
+                  </a:extLst>
+                </a:gridCol>
+                <a:gridCol w="1097280">
+                  <a:extLst>
+                    <a:ext uri="{9D8B030D-6E8A-4147-A177-3AD203B41FA5}">
+                      <a16:colId xmlns:a16="http://schemas.microsoft.com/office/drawing/2014/main" val="20003"/>
+                    </a:ext>
+                  </a:extLst>
+                </a:gridCol>
+                <a:gridCol w="1097280">
+                  <a:extLst>
+                    <a:ext uri="{9D8B030D-6E8A-4147-A177-3AD203B41FA5}">
+                      <a16:colId xmlns:a16="http://schemas.microsoft.com/office/drawing/2014/main" val="20004"/>
+                    </a:ext>
+                  </a:extLst>
+                </a:gridCol>
               </a:tblGrid>
               <a:tr h="822960">
                 <a:tc>
@@ -6621,6 +6805,11 @@
                     </a:solidFill>
                   </a:tcPr>
                 </a:tc>
+                <a:extLst>
+                  <a:ext uri="{0D108BD9-81ED-4DB2-BD59-A6C34878D82A}">
+                    <a16:rowId xmlns:a16="http://schemas.microsoft.com/office/drawing/2014/main" val="10000"/>
+                  </a:ext>
+                </a:extLst>
               </a:tr>
               <a:tr h="822960">
                 <a:tc>
@@ -6743,6 +6932,11 @@
                     </a:solidFill>
                   </a:tcPr>
                 </a:tc>
+                <a:extLst>
+                  <a:ext uri="{0D108BD9-81ED-4DB2-BD59-A6C34878D82A}">
+                    <a16:rowId xmlns:a16="http://schemas.microsoft.com/office/drawing/2014/main" val="10001"/>
+                  </a:ext>
+                </a:extLst>
               </a:tr>
               <a:tr h="822960">
                 <a:tc>
@@ -6865,6 +7059,11 @@
                     </a:solidFill>
                   </a:tcPr>
                 </a:tc>
+                <a:extLst>
+                  <a:ext uri="{0D108BD9-81ED-4DB2-BD59-A6C34878D82A}">
+                    <a16:rowId xmlns:a16="http://schemas.microsoft.com/office/drawing/2014/main" val="10002"/>
+                  </a:ext>
+                </a:extLst>
               </a:tr>
               <a:tr h="822960">
                 <a:tc>
@@ -6987,6 +7186,11 @@
                     </a:solidFill>
                   </a:tcPr>
                 </a:tc>
+                <a:extLst>
+                  <a:ext uri="{0D108BD9-81ED-4DB2-BD59-A6C34878D82A}">
+                    <a16:rowId xmlns:a16="http://schemas.microsoft.com/office/drawing/2014/main" val="10003"/>
+                  </a:ext>
+                </a:extLst>
               </a:tr>
               <a:tr h="822960">
                 <a:tc>
@@ -7109,6 +7313,11 @@
                     </a:solidFill>
                   </a:tcPr>
                 </a:tc>
+                <a:extLst>
+                  <a:ext uri="{0D108BD9-81ED-4DB2-BD59-A6C34878D82A}">
+                    <a16:rowId xmlns:a16="http://schemas.microsoft.com/office/drawing/2014/main" val="10004"/>
+                  </a:ext>
+                </a:extLst>
               </a:tr>
             </a:tbl>
           </a:graphicData>
@@ -7291,7 +7500,7 @@
 </file>
 
 <file path=ppt/slides/slide9.xml><?xml version="1.0" encoding="utf-8"?>
-<p:sld xmlns:a="http://schemas.openxmlformats.org/drawingml/2006/main" xmlns:p="http://schemas.openxmlformats.org/presentationml/2006/main" xmlns:r="http://schemas.openxmlformats.org/officeDocument/2006/relationships">
+<p:sld xmlns:a="http://schemas.openxmlformats.org/drawingml/2006/main" xmlns:r="http://schemas.openxmlformats.org/officeDocument/2006/relationships" xmlns:p="http://schemas.openxmlformats.org/presentationml/2006/main">
   <p:cSld>
     <p:bg>
       <p:bgPr>
@@ -7307,7 +7516,14 @@
         <p:cNvGrpSpPr/>
         <p:nvPr/>
       </p:nvGrpSpPr>
-      <p:grpSpPr/>
+      <p:grpSpPr>
+        <a:xfrm>
+          <a:off x="0" y="0"/>
+          <a:ext cx="0" cy="0"/>
+          <a:chOff x="0" y="0"/>
+          <a:chExt cx="0" cy="0"/>
+        </a:xfrm>
+      </p:grpSpPr>
       <p:sp>
         <p:nvSpPr>
           <p:cNvPr id="2" name="TextBox 1"/>
@@ -7420,6 +7636,7 @@
           <a:lstStyle/>
           <a:p>
             <a:pPr algn="ctr"/>
+            <a:endParaRPr/>
           </a:p>
         </p:txBody>
       </p:sp>
@@ -7442,11 +7659,41 @@
                 <a:tableStyleId>{5C22544A-7EE6-4342-B048-85BDC9FD1C3A}</a:tableStyleId>
               </a:tblPr>
               <a:tblGrid>
-                <a:gridCol w="1097280"/>
-                <a:gridCol w="1097280"/>
-                <a:gridCol w="1097280"/>
-                <a:gridCol w="1097280"/>
-                <a:gridCol w="1097280"/>
+                <a:gridCol w="1097280">
+                  <a:extLst>
+                    <a:ext uri="{9D8B030D-6E8A-4147-A177-3AD203B41FA5}">
+                      <a16:colId xmlns:a16="http://schemas.microsoft.com/office/drawing/2014/main" val="20000"/>
+                    </a:ext>
+                  </a:extLst>
+                </a:gridCol>
+                <a:gridCol w="1097280">
+                  <a:extLst>
+                    <a:ext uri="{9D8B030D-6E8A-4147-A177-3AD203B41FA5}">
+                      <a16:colId xmlns:a16="http://schemas.microsoft.com/office/drawing/2014/main" val="20001"/>
+                    </a:ext>
+                  </a:extLst>
+                </a:gridCol>
+                <a:gridCol w="1097280">
+                  <a:extLst>
+                    <a:ext uri="{9D8B030D-6E8A-4147-A177-3AD203B41FA5}">
+                      <a16:colId xmlns:a16="http://schemas.microsoft.com/office/drawing/2014/main" val="20002"/>
+                    </a:ext>
+                  </a:extLst>
+                </a:gridCol>
+                <a:gridCol w="1097280">
+                  <a:extLst>
+                    <a:ext uri="{9D8B030D-6E8A-4147-A177-3AD203B41FA5}">
+                      <a16:colId xmlns:a16="http://schemas.microsoft.com/office/drawing/2014/main" val="20003"/>
+                    </a:ext>
+                  </a:extLst>
+                </a:gridCol>
+                <a:gridCol w="1097280">
+                  <a:extLst>
+                    <a:ext uri="{9D8B030D-6E8A-4147-A177-3AD203B41FA5}">
+                      <a16:colId xmlns:a16="http://schemas.microsoft.com/office/drawing/2014/main" val="20004"/>
+                    </a:ext>
+                  </a:extLst>
+                </a:gridCol>
               </a:tblGrid>
               <a:tr h="822960">
                 <a:tc>
@@ -7569,6 +7816,11 @@
                     </a:solidFill>
                   </a:tcPr>
                 </a:tc>
+                <a:extLst>
+                  <a:ext uri="{0D108BD9-81ED-4DB2-BD59-A6C34878D82A}">
+                    <a16:rowId xmlns:a16="http://schemas.microsoft.com/office/drawing/2014/main" val="10000"/>
+                  </a:ext>
+                </a:extLst>
               </a:tr>
               <a:tr h="822960">
                 <a:tc>
@@ -7691,6 +7943,11 @@
                     </a:solidFill>
                   </a:tcPr>
                 </a:tc>
+                <a:extLst>
+                  <a:ext uri="{0D108BD9-81ED-4DB2-BD59-A6C34878D82A}">
+                    <a16:rowId xmlns:a16="http://schemas.microsoft.com/office/drawing/2014/main" val="10001"/>
+                  </a:ext>
+                </a:extLst>
               </a:tr>
               <a:tr h="822960">
                 <a:tc>
@@ -7813,6 +8070,11 @@
                     </a:solidFill>
                   </a:tcPr>
                 </a:tc>
+                <a:extLst>
+                  <a:ext uri="{0D108BD9-81ED-4DB2-BD59-A6C34878D82A}">
+                    <a16:rowId xmlns:a16="http://schemas.microsoft.com/office/drawing/2014/main" val="10002"/>
+                  </a:ext>
+                </a:extLst>
               </a:tr>
               <a:tr h="822960">
                 <a:tc>
@@ -7935,6 +8197,11 @@
                     </a:solidFill>
                   </a:tcPr>
                 </a:tc>
+                <a:extLst>
+                  <a:ext uri="{0D108BD9-81ED-4DB2-BD59-A6C34878D82A}">
+                    <a16:rowId xmlns:a16="http://schemas.microsoft.com/office/drawing/2014/main" val="10003"/>
+                  </a:ext>
+                </a:extLst>
               </a:tr>
               <a:tr h="822960">
                 <a:tc>
@@ -8057,6 +8324,11 @@
                     </a:solidFill>
                   </a:tcPr>
                 </a:tc>
+                <a:extLst>
+                  <a:ext uri="{0D108BD9-81ED-4DB2-BD59-A6C34878D82A}">
+                    <a16:rowId xmlns:a16="http://schemas.microsoft.com/office/drawing/2014/main" val="10004"/>
+                  </a:ext>
+                </a:extLst>
               </a:tr>
             </a:tbl>
           </a:graphicData>
@@ -8146,6 +8418,7 @@
               <a:t>Сравнение начальных планов:</a:t>
             </a:r>
             <a:br/>
+            <a:endParaRPr/>
           </a:p>
           <a:p>
             <a:pPr>

</xml_diff>